<commit_message>
Updated versions of the DataFormats figure
Signed-off-by: Paolo Ribeca <paolo.ribeca@gmail.com>
</commit_message>
<xml_diff>
--- a/images/KPop-DataFormats.pptx
+++ b/images/KPop-DataFormats.pptx
@@ -243,7 +243,7 @@
           <a:p>
             <a:fld id="{54D45CC1-0958-4856-BFA7-DB597C62ADE2}" type="datetimeFigureOut">
               <a:rPr lang="en-GB" smtClean="0"/>
-              <a:t>15/06/2023</a:t>
+              <a:t>12/01/2026</a:t>
             </a:fld>
             <a:endParaRPr lang="en-GB"/>
           </a:p>
@@ -413,7 +413,7 @@
           <a:p>
             <a:fld id="{54D45CC1-0958-4856-BFA7-DB597C62ADE2}" type="datetimeFigureOut">
               <a:rPr lang="en-GB" smtClean="0"/>
-              <a:t>15/06/2023</a:t>
+              <a:t>12/01/2026</a:t>
             </a:fld>
             <a:endParaRPr lang="en-GB"/>
           </a:p>
@@ -593,7 +593,7 @@
           <a:p>
             <a:fld id="{54D45CC1-0958-4856-BFA7-DB597C62ADE2}" type="datetimeFigureOut">
               <a:rPr lang="en-GB" smtClean="0"/>
-              <a:t>15/06/2023</a:t>
+              <a:t>12/01/2026</a:t>
             </a:fld>
             <a:endParaRPr lang="en-GB"/>
           </a:p>
@@ -763,7 +763,7 @@
           <a:p>
             <a:fld id="{54D45CC1-0958-4856-BFA7-DB597C62ADE2}" type="datetimeFigureOut">
               <a:rPr lang="en-GB" smtClean="0"/>
-              <a:t>15/06/2023</a:t>
+              <a:t>12/01/2026</a:t>
             </a:fld>
             <a:endParaRPr lang="en-GB"/>
           </a:p>
@@ -1007,7 +1007,7 @@
           <a:p>
             <a:fld id="{54D45CC1-0958-4856-BFA7-DB597C62ADE2}" type="datetimeFigureOut">
               <a:rPr lang="en-GB" smtClean="0"/>
-              <a:t>15/06/2023</a:t>
+              <a:t>12/01/2026</a:t>
             </a:fld>
             <a:endParaRPr lang="en-GB"/>
           </a:p>
@@ -1239,7 +1239,7 @@
           <a:p>
             <a:fld id="{54D45CC1-0958-4856-BFA7-DB597C62ADE2}" type="datetimeFigureOut">
               <a:rPr lang="en-GB" smtClean="0"/>
-              <a:t>15/06/2023</a:t>
+              <a:t>12/01/2026</a:t>
             </a:fld>
             <a:endParaRPr lang="en-GB"/>
           </a:p>
@@ -1606,7 +1606,7 @@
           <a:p>
             <a:fld id="{54D45CC1-0958-4856-BFA7-DB597C62ADE2}" type="datetimeFigureOut">
               <a:rPr lang="en-GB" smtClean="0"/>
-              <a:t>15/06/2023</a:t>
+              <a:t>12/01/2026</a:t>
             </a:fld>
             <a:endParaRPr lang="en-GB"/>
           </a:p>
@@ -1724,7 +1724,7 @@
           <a:p>
             <a:fld id="{54D45CC1-0958-4856-BFA7-DB597C62ADE2}" type="datetimeFigureOut">
               <a:rPr lang="en-GB" smtClean="0"/>
-              <a:t>15/06/2023</a:t>
+              <a:t>12/01/2026</a:t>
             </a:fld>
             <a:endParaRPr lang="en-GB"/>
           </a:p>
@@ -1819,7 +1819,7 @@
           <a:p>
             <a:fld id="{54D45CC1-0958-4856-BFA7-DB597C62ADE2}" type="datetimeFigureOut">
               <a:rPr lang="en-GB" smtClean="0"/>
-              <a:t>15/06/2023</a:t>
+              <a:t>12/01/2026</a:t>
             </a:fld>
             <a:endParaRPr lang="en-GB"/>
           </a:p>
@@ -2096,7 +2096,7 @@
           <a:p>
             <a:fld id="{54D45CC1-0958-4856-BFA7-DB597C62ADE2}" type="datetimeFigureOut">
               <a:rPr lang="en-GB" smtClean="0"/>
-              <a:t>15/06/2023</a:t>
+              <a:t>12/01/2026</a:t>
             </a:fld>
             <a:endParaRPr lang="en-GB"/>
           </a:p>
@@ -2353,7 +2353,7 @@
           <a:p>
             <a:fld id="{54D45CC1-0958-4856-BFA7-DB597C62ADE2}" type="datetimeFigureOut">
               <a:rPr lang="en-GB" smtClean="0"/>
-              <a:t>15/06/2023</a:t>
+              <a:t>12/01/2026</a:t>
             </a:fld>
             <a:endParaRPr lang="en-GB"/>
           </a:p>
@@ -2566,7 +2566,7 @@
           <a:p>
             <a:fld id="{54D45CC1-0958-4856-BFA7-DB597C62ADE2}" type="datetimeFigureOut">
               <a:rPr lang="en-GB" smtClean="0"/>
-              <a:t>15/06/2023</a:t>
+              <a:t>12/01/2026</a:t>
             </a:fld>
             <a:endParaRPr lang="en-GB"/>
           </a:p>
@@ -3025,6 +3025,13 @@
               <a:t>Reads (FASTQ)</a:t>
             </a:r>
           </a:p>
+          <a:p>
+            <a:pPr algn="ctr"/>
+            <a:r>
+              <a:rPr lang="en-GB" sz="1001" dirty="0"/>
+              <a:t>Tab-separated</a:t>
+            </a:r>
+          </a:p>
         </p:txBody>
       </p:sp>
       <p:sp>
@@ -3049,19 +3056,17 @@
           </a:prstGeom>
         </p:spPr>
         <p:style>
-          <a:lnRef idx="2">
-            <a:schemeClr val="dk1">
-              <a:shade val="50000"/>
-            </a:schemeClr>
+          <a:lnRef idx="1">
+            <a:schemeClr val="dk1"/>
           </a:lnRef>
-          <a:fillRef idx="1">
+          <a:fillRef idx="2">
             <a:schemeClr val="dk1"/>
           </a:fillRef>
-          <a:effectRef idx="0">
+          <a:effectRef idx="1">
             <a:schemeClr val="dk1"/>
           </a:effectRef>
           <a:fontRef idx="minor">
-            <a:schemeClr val="lt1"/>
+            <a:schemeClr val="dk1"/>
           </a:fontRef>
         </p:style>
         <p:txBody>
@@ -3083,14 +3088,22 @@
             </a:r>
             <a:r>
               <a:rPr lang="en-GB" sz="1001" dirty="0"/>
-              <a:t> spectra</a:t>
+              <a:t> spectra DB</a:t>
             </a:r>
           </a:p>
           <a:p>
             <a:pPr algn="ctr"/>
             <a:r>
               <a:rPr lang="en-GB" sz="1001" dirty="0"/>
-              <a:t>(tab-separated) </a:t>
+              <a:t>(binary, .</a:t>
+            </a:r>
+            <a:r>
+              <a:rPr lang="en-GB" sz="1001" dirty="0" err="1"/>
+              <a:t>KPopSpectra</a:t>
+            </a:r>
+            <a:r>
+              <a:rPr lang="en-GB" sz="1001" dirty="0"/>
+              <a:t>) </a:t>
             </a:r>
           </a:p>
         </p:txBody>
@@ -3160,7 +3173,7 @@
             </a:r>
             <a:r>
               <a:rPr lang="en-GB" sz="1001" dirty="0" err="1"/>
-              <a:t>KPopCounter</a:t>
+              <a:t>KPopSpectra</a:t>
             </a:r>
             <a:r>
               <a:rPr lang="en-GB" sz="1001" dirty="0"/>
@@ -3241,19 +3254,17 @@
           </a:prstGeom>
         </p:spPr>
         <p:style>
-          <a:lnRef idx="2">
-            <a:schemeClr val="dk1">
-              <a:shade val="50000"/>
-            </a:schemeClr>
+          <a:lnRef idx="1">
+            <a:schemeClr val="dk1"/>
           </a:lnRef>
-          <a:fillRef idx="1">
+          <a:fillRef idx="2">
             <a:schemeClr val="dk1"/>
           </a:fillRef>
-          <a:effectRef idx="0">
+          <a:effectRef idx="1">
             <a:schemeClr val="dk1"/>
           </a:effectRef>
           <a:fontRef idx="minor">
-            <a:schemeClr val="lt1"/>
+            <a:schemeClr val="dk1"/>
           </a:fontRef>
         </p:style>
         <p:txBody>
@@ -3275,14 +3286,22 @@
             </a:r>
             <a:r>
               <a:rPr lang="en-GB" sz="1001" dirty="0"/>
-              <a:t> spectra</a:t>
+              <a:t> spectra DB</a:t>
             </a:r>
           </a:p>
           <a:p>
             <a:pPr algn="ctr"/>
             <a:r>
               <a:rPr lang="en-GB" sz="1001" dirty="0"/>
-              <a:t>(tab-separated) </a:t>
+              <a:t>(binary, .</a:t>
+            </a:r>
+            <a:r>
+              <a:rPr lang="en-GB" sz="1001" dirty="0" err="1"/>
+              <a:t>KPopSpectra</a:t>
+            </a:r>
+            <a:r>
+              <a:rPr lang="en-GB" sz="1001" dirty="0"/>
+              <a:t>) </a:t>
             </a:r>
           </a:p>
         </p:txBody>
@@ -3631,19 +3650,17 @@
           </a:prstGeom>
         </p:spPr>
         <p:style>
-          <a:lnRef idx="2">
-            <a:schemeClr val="dk1">
-              <a:shade val="50000"/>
-            </a:schemeClr>
+          <a:lnRef idx="1">
+            <a:schemeClr val="dk1"/>
           </a:lnRef>
-          <a:fillRef idx="1">
+          <a:fillRef idx="2">
             <a:schemeClr val="dk1"/>
           </a:fillRef>
-          <a:effectRef idx="0">
+          <a:effectRef idx="1">
             <a:schemeClr val="dk1"/>
           </a:effectRef>
           <a:fontRef idx="minor">
-            <a:schemeClr val="lt1"/>
+            <a:schemeClr val="dk1"/>
           </a:fontRef>
         </p:style>
         <p:txBody>
@@ -3665,14 +3682,22 @@
             </a:r>
             <a:r>
               <a:rPr lang="en-GB" sz="1001" dirty="0"/>
-              <a:t> spectra</a:t>
+              <a:t> spectra DB</a:t>
             </a:r>
           </a:p>
           <a:p>
             <a:pPr algn="ctr"/>
             <a:r>
               <a:rPr lang="en-GB" sz="1001" dirty="0"/>
-              <a:t>(tab-separated) </a:t>
+              <a:t>(binary, .</a:t>
+            </a:r>
+            <a:r>
+              <a:rPr lang="en-GB" sz="1001" dirty="0" err="1"/>
+              <a:t>KPopSpectra</a:t>
+            </a:r>
+            <a:r>
+              <a:rPr lang="en-GB" sz="1001" dirty="0"/>
+              <a:t>) </a:t>
             </a:r>
           </a:p>
         </p:txBody>
@@ -3742,7 +3767,7 @@
             </a:r>
             <a:r>
               <a:rPr lang="en-GB" sz="1001" dirty="0" err="1"/>
-              <a:t>KPopCounter</a:t>
+              <a:t>KPopSpectra</a:t>
             </a:r>
             <a:r>
               <a:rPr lang="en-GB" sz="1001" dirty="0"/>
@@ -3997,7 +4022,7 @@
             </a:r>
             <a:r>
               <a:rPr lang="en-GB" sz="1001" dirty="0" err="1"/>
-              <a:t>KPopCounter</a:t>
+              <a:t>KPopSpectra</a:t>
             </a:r>
             <a:r>
               <a:rPr lang="en-GB" sz="1001" dirty="0"/>
@@ -4284,7 +4309,7 @@
             </a:r>
             <a:r>
               <a:rPr lang="en-GB" sz="1001" dirty="0" err="1"/>
-              <a:t>KPopCounter</a:t>
+              <a:t>KPopSpectra</a:t>
             </a:r>
             <a:r>
               <a:rPr lang="en-GB" sz="1001" dirty="0"/>
@@ -4607,7 +4632,7 @@
             </a:r>
             <a:r>
               <a:rPr lang="en-GB" sz="1001" dirty="0" err="1"/>
-              <a:t>KPopCounter</a:t>
+              <a:t>KPopSpectra</a:t>
             </a:r>
             <a:r>
               <a:rPr lang="en-GB" sz="1001" dirty="0"/>
@@ -4638,19 +4663,17 @@
           </a:prstGeom>
         </p:spPr>
         <p:style>
-          <a:lnRef idx="2">
-            <a:schemeClr val="dk1">
-              <a:shade val="50000"/>
-            </a:schemeClr>
+          <a:lnRef idx="1">
+            <a:schemeClr val="dk1"/>
           </a:lnRef>
-          <a:fillRef idx="1">
+          <a:fillRef idx="2">
             <a:schemeClr val="dk1"/>
           </a:fillRef>
-          <a:effectRef idx="0">
+          <a:effectRef idx="1">
             <a:schemeClr val="dk1"/>
           </a:effectRef>
           <a:fontRef idx="minor">
-            <a:schemeClr val="lt1"/>
+            <a:schemeClr val="dk1"/>
           </a:fontRef>
         </p:style>
         <p:txBody>
@@ -4679,8 +4702,17 @@
             <a:pPr algn="ctr"/>
             <a:r>
               <a:rPr lang="en-GB" sz="1001" dirty="0"/>
-              <a:t>(tab-separated) </a:t>
-            </a:r>
+              <a:t>(binary, .</a:t>
+            </a:r>
+            <a:r>
+              <a:rPr lang="en-GB" sz="1001" dirty="0" err="1"/>
+              <a:t>KPopSpectra</a:t>
+            </a:r>
+            <a:r>
+              <a:rPr lang="en-GB" sz="1001"/>
+              <a:t>) </a:t>
+            </a:r>
+            <a:endParaRPr lang="en-GB" sz="1001" dirty="0"/>
           </a:p>
         </p:txBody>
       </p:sp>
@@ -4706,19 +4738,17 @@
           </a:prstGeom>
         </p:spPr>
         <p:style>
-          <a:lnRef idx="2">
-            <a:schemeClr val="dk1">
-              <a:shade val="50000"/>
-            </a:schemeClr>
+          <a:lnRef idx="1">
+            <a:schemeClr val="dk1"/>
           </a:lnRef>
-          <a:fillRef idx="1">
+          <a:fillRef idx="2">
             <a:schemeClr val="dk1"/>
           </a:fillRef>
-          <a:effectRef idx="0">
+          <a:effectRef idx="1">
             <a:schemeClr val="dk1"/>
           </a:effectRef>
           <a:fontRef idx="minor">
-            <a:schemeClr val="lt1"/>
+            <a:schemeClr val="dk1"/>
           </a:fontRef>
         </p:style>
         <p:txBody>
@@ -4740,14 +4770,22 @@
             </a:r>
             <a:r>
               <a:rPr lang="en-GB" sz="1001" dirty="0"/>
-              <a:t> spectra</a:t>
+              <a:t> spectra DB</a:t>
             </a:r>
           </a:p>
           <a:p>
             <a:pPr algn="ctr"/>
             <a:r>
               <a:rPr lang="en-GB" sz="1001" dirty="0"/>
-              <a:t>(tab-separated) </a:t>
+              <a:t>(binary, .</a:t>
+            </a:r>
+            <a:r>
+              <a:rPr lang="en-GB" sz="1001" dirty="0" err="1"/>
+              <a:t>KPopSpectra</a:t>
+            </a:r>
+            <a:r>
+              <a:rPr lang="en-GB" sz="1001" dirty="0"/>
+              <a:t>) </a:t>
             </a:r>
           </a:p>
         </p:txBody>
@@ -5073,75 +5111,6 @@
       </p:sp>
       <p:sp>
         <p:nvSpPr>
-          <p:cNvPr id="184" name="Rectangle 183">
-            <a:extLst>
-              <a:ext uri="{FF2B5EF4-FFF2-40B4-BE49-F238E27FC236}">
-                <a16:creationId xmlns:a16="http://schemas.microsoft.com/office/drawing/2014/main" id="{C465371D-49EE-60E9-6C86-103D097AF3E7}"/>
-              </a:ext>
-            </a:extLst>
-          </p:cNvPr>
-          <p:cNvSpPr/>
-          <p:nvPr/>
-        </p:nvSpPr>
-        <p:spPr>
-          <a:xfrm>
-            <a:off x="8321562" y="4825448"/>
-            <a:ext cx="1218853" cy="563658"/>
-          </a:xfrm>
-          <a:prstGeom prst="rect">
-            <a:avLst/>
-          </a:prstGeom>
-        </p:spPr>
-        <p:style>
-          <a:lnRef idx="1">
-            <a:schemeClr val="dk1"/>
-          </a:lnRef>
-          <a:fillRef idx="2">
-            <a:schemeClr val="dk1"/>
-          </a:fillRef>
-          <a:effectRef idx="1">
-            <a:schemeClr val="dk1"/>
-          </a:effectRef>
-          <a:fontRef idx="minor">
-            <a:schemeClr val="dk1"/>
-          </a:fontRef>
-        </p:style>
-        <p:txBody>
-          <a:bodyPr rtlCol="0" anchor="ctr"/>
-          <a:lstStyle/>
-          <a:p>
-            <a:pPr algn="ctr"/>
-            <a:r>
-              <a:rPr lang="en-GB" sz="1001" dirty="0"/>
-              <a:t>Distance matrix</a:t>
-            </a:r>
-          </a:p>
-          <a:p>
-            <a:pPr algn="ctr"/>
-            <a:r>
-              <a:rPr lang="en-GB" sz="1001" dirty="0"/>
-              <a:t>(binary,</a:t>
-            </a:r>
-          </a:p>
-          <a:p>
-            <a:pPr algn="ctr"/>
-            <a:r>
-              <a:rPr lang="en-GB" sz="1001" dirty="0"/>
-              <a:t>.</a:t>
-            </a:r>
-            <a:r>
-              <a:rPr lang="en-GB" sz="1001" dirty="0" err="1"/>
-              <a:t>KPopDMatrix</a:t>
-            </a:r>
-            <a:r>
-              <a:rPr lang="en-GB" sz="1001" dirty="0"/>
-              <a:t>) </a:t>
-            </a:r>
-          </a:p>
-        </p:txBody>
-      </p:sp>
-      <p:sp>
-        <p:nvSpPr>
           <p:cNvPr id="185" name="Oval 184">
             <a:extLst>
               <a:ext uri="{FF2B5EF4-FFF2-40B4-BE49-F238E27FC236}">
@@ -5215,50 +5184,7 @@
             <a:avLst/>
           </a:prstGeom>
           <a:ln>
-            <a:prstDash val="solid"/>
-            <a:tailEnd type="triangle"/>
-          </a:ln>
-        </p:spPr>
-        <p:style>
-          <a:lnRef idx="3">
-            <a:schemeClr val="dk1"/>
-          </a:lnRef>
-          <a:fillRef idx="0">
-            <a:schemeClr val="dk1"/>
-          </a:fillRef>
-          <a:effectRef idx="2">
-            <a:schemeClr val="dk1"/>
-          </a:effectRef>
-          <a:fontRef idx="minor">
-            <a:schemeClr val="tx1"/>
-          </a:fontRef>
-        </p:style>
-      </p:cxnSp>
-      <p:cxnSp>
-        <p:nvCxnSpPr>
-          <p:cNvPr id="187" name="Straight Arrow Connector 186">
-            <a:extLst>
-              <a:ext uri="{FF2B5EF4-FFF2-40B4-BE49-F238E27FC236}">
-                <a16:creationId xmlns:a16="http://schemas.microsoft.com/office/drawing/2014/main" id="{4AAB3377-89C3-4D28-D06E-8493300443C6}"/>
-              </a:ext>
-            </a:extLst>
-          </p:cNvPr>
-          <p:cNvCxnSpPr>
-            <a:cxnSpLocks/>
-            <a:stCxn id="185" idx="6"/>
-            <a:endCxn id="184" idx="1"/>
-          </p:cNvCxnSpPr>
-          <p:nvPr/>
-        </p:nvCxnSpPr>
-        <p:spPr>
-          <a:xfrm>
-            <a:off x="8101197" y="5104897"/>
-            <a:ext cx="220365" cy="2380"/>
-          </a:xfrm>
-          <a:prstGeom prst="straightConnector1">
-            <a:avLst/>
-          </a:prstGeom>
-          <a:ln>
+            <a:prstDash val="dash"/>
             <a:tailEnd type="triangle"/>
           </a:ln>
         </p:spPr>
@@ -5635,24 +5561,31 @@
           <a:p>
             <a:pPr algn="ctr"/>
             <a:r>
-              <a:rPr lang="en-GB" sz="1001"/>
-              <a:t>Distance matrix</a:t>
+              <a:rPr lang="en-GB" sz="1001" dirty="0"/>
+              <a:t>Twisted spectra</a:t>
             </a:r>
           </a:p>
           <a:p>
             <a:pPr algn="ctr"/>
             <a:r>
-              <a:rPr lang="en-GB" sz="1001"/>
+              <a:rPr lang="en-GB" sz="1001" dirty="0"/>
               <a:t>(binary,</a:t>
             </a:r>
           </a:p>
           <a:p>
             <a:pPr algn="ctr"/>
             <a:r>
-              <a:rPr lang="en-GB" sz="1001"/>
-              <a:t>.KPopDMatrix) </a:t>
-            </a:r>
-            <a:endParaRPr lang="en-GB" sz="1001" dirty="0"/>
+              <a:rPr lang="en-GB" sz="1001" dirty="0"/>
+              <a:t>.</a:t>
+            </a:r>
+            <a:r>
+              <a:rPr lang="en-GB" sz="1001" dirty="0" err="1"/>
+              <a:t>KPopTwisted</a:t>
+            </a:r>
+            <a:r>
+              <a:rPr lang="en-GB" sz="1001" dirty="0"/>
+              <a:t>) </a:t>
+            </a:r>
           </a:p>
         </p:txBody>
       </p:sp>
@@ -5700,7 +5633,7 @@
             <a:pPr algn="ctr"/>
             <a:r>
               <a:rPr lang="en-GB" sz="1001" dirty="0"/>
-              <a:t>Distance summary</a:t>
+              <a:t>Embeddings</a:t>
             </a:r>
           </a:p>
           <a:p>
@@ -5714,7 +5647,7 @@
             <a:pPr algn="ctr"/>
             <a:r>
               <a:rPr lang="en-GB" sz="1001" dirty="0"/>
-              <a:t>.KPopSummary.txt) </a:t>
+              <a:t>.KPopVectors.txt) </a:t>
             </a:r>
           </a:p>
         </p:txBody>
@@ -5973,6 +5906,255 @@
           </a:p>
         </p:txBody>
       </p:sp>
+      <p:sp>
+        <p:nvSpPr>
+          <p:cNvPr id="3" name="Rectangle 2">
+            <a:extLst>
+              <a:ext uri="{FF2B5EF4-FFF2-40B4-BE49-F238E27FC236}">
+                <a16:creationId xmlns:a16="http://schemas.microsoft.com/office/drawing/2014/main" id="{8DF97006-DF27-A899-2988-C1110B66C13A}"/>
+              </a:ext>
+            </a:extLst>
+          </p:cNvPr>
+          <p:cNvSpPr/>
+          <p:nvPr/>
+        </p:nvSpPr>
+        <p:spPr>
+          <a:xfrm>
+            <a:off x="8315374" y="4456655"/>
+            <a:ext cx="1219728" cy="563658"/>
+          </a:xfrm>
+          <a:prstGeom prst="rect">
+            <a:avLst/>
+          </a:prstGeom>
+        </p:spPr>
+        <p:style>
+          <a:lnRef idx="2">
+            <a:schemeClr val="dk1">
+              <a:shade val="50000"/>
+            </a:schemeClr>
+          </a:lnRef>
+          <a:fillRef idx="1">
+            <a:schemeClr val="dk1"/>
+          </a:fillRef>
+          <a:effectRef idx="0">
+            <a:schemeClr val="dk1"/>
+          </a:effectRef>
+          <a:fontRef idx="minor">
+            <a:schemeClr val="lt1"/>
+          </a:fontRef>
+        </p:style>
+        <p:txBody>
+          <a:bodyPr rtlCol="0" anchor="ctr"/>
+          <a:lstStyle/>
+          <a:p>
+            <a:pPr algn="ctr"/>
+            <a:r>
+              <a:rPr lang="en-GB" sz="1001" dirty="0">
+                <a:solidFill>
+                  <a:schemeClr val="lt1"/>
+                </a:solidFill>
+              </a:rPr>
+              <a:t>Distance summary</a:t>
+            </a:r>
+          </a:p>
+          <a:p>
+            <a:pPr algn="ctr"/>
+            <a:r>
+              <a:rPr lang="en-GB" sz="1001" dirty="0">
+                <a:solidFill>
+                  <a:schemeClr val="lt1"/>
+                </a:solidFill>
+              </a:rPr>
+              <a:t>(tab-separated,</a:t>
+            </a:r>
+          </a:p>
+          <a:p>
+            <a:pPr algn="ctr"/>
+            <a:r>
+              <a:rPr lang="en-GB" sz="1001" dirty="0">
+                <a:solidFill>
+                  <a:schemeClr val="lt1"/>
+                </a:solidFill>
+              </a:rPr>
+              <a:t>.KPopSummary.txt) </a:t>
+            </a:r>
+          </a:p>
+        </p:txBody>
+      </p:sp>
+      <p:cxnSp>
+        <p:nvCxnSpPr>
+          <p:cNvPr id="4" name="Straight Arrow Connector 3">
+            <a:extLst>
+              <a:ext uri="{FF2B5EF4-FFF2-40B4-BE49-F238E27FC236}">
+                <a16:creationId xmlns:a16="http://schemas.microsoft.com/office/drawing/2014/main" id="{A7DF3227-AF75-B6C4-07B7-7338D179DB30}"/>
+              </a:ext>
+            </a:extLst>
+          </p:cNvPr>
+          <p:cNvCxnSpPr>
+            <a:cxnSpLocks/>
+            <a:stCxn id="185" idx="6"/>
+            <a:endCxn id="3" idx="1"/>
+          </p:cNvCxnSpPr>
+          <p:nvPr/>
+        </p:nvCxnSpPr>
+        <p:spPr>
+          <a:xfrm flipV="1">
+            <a:off x="8101197" y="4738484"/>
+            <a:ext cx="214177" cy="366413"/>
+          </a:xfrm>
+          <a:prstGeom prst="straightConnector1">
+            <a:avLst/>
+          </a:prstGeom>
+          <a:ln>
+            <a:tailEnd type="triangle"/>
+          </a:ln>
+        </p:spPr>
+        <p:style>
+          <a:lnRef idx="3">
+            <a:schemeClr val="dk1"/>
+          </a:lnRef>
+          <a:fillRef idx="0">
+            <a:schemeClr val="dk1"/>
+          </a:fillRef>
+          <a:effectRef idx="2">
+            <a:schemeClr val="dk1"/>
+          </a:effectRef>
+          <a:fontRef idx="minor">
+            <a:schemeClr val="tx1"/>
+          </a:fontRef>
+        </p:style>
+      </p:cxnSp>
+      <p:sp>
+        <p:nvSpPr>
+          <p:cNvPr id="5" name="Rectangle 4">
+            <a:extLst>
+              <a:ext uri="{FF2B5EF4-FFF2-40B4-BE49-F238E27FC236}">
+                <a16:creationId xmlns:a16="http://schemas.microsoft.com/office/drawing/2014/main" id="{82785C0E-3D0A-0E2F-83AF-0C4AB14F9A74}"/>
+              </a:ext>
+            </a:extLst>
+          </p:cNvPr>
+          <p:cNvSpPr/>
+          <p:nvPr/>
+        </p:nvSpPr>
+        <p:spPr>
+          <a:xfrm>
+            <a:off x="8315374" y="5175278"/>
+            <a:ext cx="1219728" cy="563658"/>
+          </a:xfrm>
+          <a:prstGeom prst="rect">
+            <a:avLst/>
+          </a:prstGeom>
+        </p:spPr>
+        <p:style>
+          <a:lnRef idx="2">
+            <a:schemeClr val="dk1">
+              <a:shade val="50000"/>
+            </a:schemeClr>
+          </a:lnRef>
+          <a:fillRef idx="1">
+            <a:schemeClr val="dk1"/>
+          </a:fillRef>
+          <a:effectRef idx="0">
+            <a:schemeClr val="dk1"/>
+          </a:effectRef>
+          <a:fontRef idx="minor">
+            <a:schemeClr val="lt1"/>
+          </a:fontRef>
+        </p:style>
+        <p:txBody>
+          <a:bodyPr rtlCol="0" anchor="ctr"/>
+          <a:lstStyle/>
+          <a:p>
+            <a:pPr algn="ctr"/>
+            <a:r>
+              <a:rPr lang="en-GB" sz="1001" dirty="0">
+                <a:solidFill>
+                  <a:schemeClr val="lt1"/>
+                </a:solidFill>
+              </a:rPr>
+              <a:t>Distance matrix</a:t>
+            </a:r>
+          </a:p>
+          <a:p>
+            <a:pPr algn="ctr"/>
+            <a:r>
+              <a:rPr lang="en-GB" sz="1001" dirty="0">
+                <a:solidFill>
+                  <a:schemeClr val="lt1"/>
+                </a:solidFill>
+              </a:rPr>
+              <a:t>(</a:t>
+            </a:r>
+            <a:r>
+              <a:rPr lang="en-GB" sz="1001" dirty="0"/>
+              <a:t>tab-separated</a:t>
+            </a:r>
+            <a:r>
+              <a:rPr lang="en-GB" sz="1001" dirty="0">
+                <a:solidFill>
+                  <a:schemeClr val="lt1"/>
+                </a:solidFill>
+              </a:rPr>
+              <a:t>,</a:t>
+            </a:r>
+          </a:p>
+          <a:p>
+            <a:pPr algn="ctr"/>
+            <a:r>
+              <a:rPr lang="en-GB" sz="1001" dirty="0">
+                <a:solidFill>
+                  <a:schemeClr val="lt1"/>
+                </a:solidFill>
+              </a:rPr>
+              <a:t>.KPopDMatrix.txt) </a:t>
+            </a:r>
+          </a:p>
+        </p:txBody>
+      </p:sp>
+      <p:cxnSp>
+        <p:nvCxnSpPr>
+          <p:cNvPr id="6" name="Straight Arrow Connector 5">
+            <a:extLst>
+              <a:ext uri="{FF2B5EF4-FFF2-40B4-BE49-F238E27FC236}">
+                <a16:creationId xmlns:a16="http://schemas.microsoft.com/office/drawing/2014/main" id="{010DD714-07E9-01B3-D040-3429F0BAA953}"/>
+              </a:ext>
+            </a:extLst>
+          </p:cNvPr>
+          <p:cNvCxnSpPr>
+            <a:cxnSpLocks/>
+            <a:stCxn id="185" idx="6"/>
+            <a:endCxn id="5" idx="1"/>
+          </p:cNvCxnSpPr>
+          <p:nvPr/>
+        </p:nvCxnSpPr>
+        <p:spPr>
+          <a:xfrm>
+            <a:off x="8101197" y="5104897"/>
+            <a:ext cx="214177" cy="352210"/>
+          </a:xfrm>
+          <a:prstGeom prst="straightConnector1">
+            <a:avLst/>
+          </a:prstGeom>
+          <a:ln>
+            <a:prstDash val="dash"/>
+            <a:tailEnd type="triangle"/>
+          </a:ln>
+        </p:spPr>
+        <p:style>
+          <a:lnRef idx="3">
+            <a:schemeClr val="dk1"/>
+          </a:lnRef>
+          <a:fillRef idx="0">
+            <a:schemeClr val="dk1"/>
+          </a:fillRef>
+          <a:effectRef idx="2">
+            <a:schemeClr val="dk1"/>
+          </a:effectRef>
+          <a:fontRef idx="minor">
+            <a:schemeClr val="tx1"/>
+          </a:fontRef>
+        </p:style>
+      </p:cxnSp>
     </p:spTree>
     <p:extLst>
       <p:ext uri="{BB962C8B-B14F-4D97-AF65-F5344CB8AC3E}">

</xml_diff>